<commit_message>
lab 2  week 10
</commit_message>
<xml_diff>
--- a/topic-10-week10/unit-2/talk-1/platforms1-2025.pptx
+++ b/topic-10-week10/unit-2/talk-1/platforms1-2025.pptx
@@ -5,7 +5,7 @@
     <p:sldMasterId id="2147483660" r:id="rId1"/>
   </p:sldMasterIdLst>
   <p:notesMasterIdLst>
-    <p:notesMasterId r:id="rId36"/>
+    <p:notesMasterId r:id="rId40"/>
   </p:notesMasterIdLst>
   <p:sldIdLst>
     <p:sldId id="256" r:id="rId2"/>
@@ -41,7 +41,11 @@
     <p:sldId id="283" r:id="rId32"/>
     <p:sldId id="266" r:id="rId33"/>
     <p:sldId id="269" r:id="rId34"/>
-    <p:sldId id="305" r:id="rId35"/>
+    <p:sldId id="306" r:id="rId35"/>
+    <p:sldId id="307" r:id="rId36"/>
+    <p:sldId id="308" r:id="rId37"/>
+    <p:sldId id="309" r:id="rId38"/>
+    <p:sldId id="305" r:id="rId39"/>
   </p:sldIdLst>
   <p:sldSz cx="12192000" cy="6858000"/>
   <p:notesSz cx="6858000" cy="9144000"/>
@@ -17860,6 +17864,900 @@
           <p:cNvPr id="2" name="Title 1">
             <a:extLst>
               <a:ext uri="{FF2B5EF4-FFF2-40B4-BE49-F238E27FC236}">
+                <a16:creationId xmlns:a16="http://schemas.microsoft.com/office/drawing/2014/main" id="{F49CF0B4-0C8C-FF8F-BF8D-D3E95D3C7590}"/>
+              </a:ext>
+            </a:extLst>
+          </p:cNvPr>
+          <p:cNvSpPr>
+            <a:spLocks noGrp="1"/>
+          </p:cNvSpPr>
+          <p:nvPr>
+            <p:ph type="title"/>
+          </p:nvPr>
+        </p:nvSpPr>
+        <p:spPr/>
+        <p:txBody>
+          <a:bodyPr/>
+          <a:lstStyle/>
+          <a:p>
+            <a:r>
+              <a:rPr lang="en-GB" dirty="0"/>
+              <a:t>Python Features: Decorators</a:t>
+            </a:r>
+            <a:endParaRPr lang="en-IE" dirty="0"/>
+          </a:p>
+        </p:txBody>
+      </p:sp>
+      <p:sp>
+        <p:nvSpPr>
+          <p:cNvPr id="3" name="Content Placeholder 2">
+            <a:extLst>
+              <a:ext uri="{FF2B5EF4-FFF2-40B4-BE49-F238E27FC236}">
+                <a16:creationId xmlns:a16="http://schemas.microsoft.com/office/drawing/2014/main" id="{658F3F83-C1FB-1DC7-161F-6F3C171FA6AD}"/>
+              </a:ext>
+            </a:extLst>
+          </p:cNvPr>
+          <p:cNvSpPr>
+            <a:spLocks noGrp="1"/>
+          </p:cNvSpPr>
+          <p:nvPr>
+            <p:ph idx="1"/>
+          </p:nvPr>
+        </p:nvSpPr>
+        <p:spPr>
+          <a:xfrm>
+            <a:off x="838200" y="1825625"/>
+            <a:ext cx="7400026" cy="4351338"/>
+          </a:xfrm>
+        </p:spPr>
+        <p:txBody>
+          <a:bodyPr>
+            <a:normAutofit fontScale="85000" lnSpcReduction="20000"/>
+          </a:bodyPr>
+          <a:lstStyle/>
+          <a:p>
+            <a:r>
+              <a:rPr lang="en-GB" dirty="0"/>
+              <a:t>A </a:t>
+            </a:r>
+            <a:r>
+              <a:rPr lang="en-GB" b="1" dirty="0"/>
+              <a:t>decorator</a:t>
+            </a:r>
+            <a:r>
+              <a:rPr lang="en-GB" dirty="0"/>
+              <a:t> is a function that:</a:t>
+            </a:r>
+          </a:p>
+          <a:p>
+            <a:pPr lvl="1"/>
+            <a:r>
+              <a:rPr lang="en-GB" dirty="0"/>
+              <a:t>Associated with function</a:t>
+            </a:r>
+          </a:p>
+          <a:p>
+            <a:pPr lvl="1"/>
+            <a:r>
+              <a:rPr lang="en-IE" dirty="0"/>
+              <a:t>Adds extra behaviour</a:t>
+            </a:r>
+          </a:p>
+          <a:p>
+            <a:r>
+              <a:rPr lang="en-IE" dirty="0"/>
+              <a:t>Example in </a:t>
+            </a:r>
+            <a:r>
+              <a:rPr lang="en-IE" b="1" dirty="0"/>
+              <a:t>Flask</a:t>
+            </a:r>
+            <a:r>
+              <a:rPr lang="en-IE" dirty="0"/>
+              <a:t>: </a:t>
+            </a:r>
+            <a:r>
+              <a:rPr lang="en-GB" dirty="0">
+                <a:highlight>
+                  <a:srgbClr val="C0C0C0"/>
+                </a:highlight>
+                <a:latin typeface="Courier New" panose="02070309020205020404" pitchFamily="49" charset="0"/>
+                <a:cs typeface="Courier New" panose="02070309020205020404" pitchFamily="49" charset="0"/>
+              </a:rPr>
+              <a:t>@app.route("/")</a:t>
+            </a:r>
+          </a:p>
+          <a:p>
+            <a:r>
+              <a:rPr lang="en-GB" dirty="0"/>
+              <a:t>It tells Flask: “When someone visits /, call the </a:t>
+            </a:r>
+            <a:r>
+              <a:rPr lang="en-GB" dirty="0">
+                <a:highlight>
+                  <a:srgbClr val="C0C0C0"/>
+                </a:highlight>
+                <a:latin typeface="Courier New" panose="02070309020205020404" pitchFamily="49" charset="0"/>
+                <a:cs typeface="Courier New" panose="02070309020205020404" pitchFamily="49" charset="0"/>
+              </a:rPr>
+              <a:t>home() </a:t>
+            </a:r>
+            <a:r>
+              <a:rPr lang="en-GB" dirty="0"/>
+              <a:t>function.”</a:t>
+            </a:r>
+          </a:p>
+          <a:p>
+            <a:r>
+              <a:rPr lang="en-GB" dirty="0"/>
+              <a:t>It wraps </a:t>
+            </a:r>
+            <a:r>
+              <a:rPr lang="en-GB" dirty="0">
+                <a:highlight>
+                  <a:srgbClr val="C0C0C0"/>
+                </a:highlight>
+                <a:latin typeface="Courier New" panose="02070309020205020404" pitchFamily="49" charset="0"/>
+                <a:cs typeface="Courier New" panose="02070309020205020404" pitchFamily="49" charset="0"/>
+              </a:rPr>
+              <a:t>home() </a:t>
+            </a:r>
+            <a:r>
+              <a:rPr lang="en-GB" dirty="0"/>
+              <a:t>with logic that:</a:t>
+            </a:r>
+          </a:p>
+          <a:p>
+            <a:pPr lvl="1"/>
+            <a:r>
+              <a:rPr lang="en-GB" dirty="0"/>
+              <a:t>Matches URLs</a:t>
+            </a:r>
+          </a:p>
+          <a:p>
+            <a:pPr lvl="1"/>
+            <a:r>
+              <a:rPr lang="en-GB" dirty="0"/>
+              <a:t>Handles HTTP requests/responses</a:t>
+            </a:r>
+          </a:p>
+          <a:p>
+            <a:pPr lvl="1"/>
+            <a:r>
+              <a:rPr lang="en-GB" dirty="0"/>
+              <a:t>You write only the core logic (return "Hello, world!"),the decorator takes care of all the web-server plumbing.</a:t>
+            </a:r>
+          </a:p>
+          <a:p>
+            <a:r>
+              <a:rPr lang="en-GB" dirty="0"/>
+              <a:t>Also used in Event Driven programming to match events to functions</a:t>
+            </a:r>
+          </a:p>
+          <a:p>
+            <a:pPr lvl="1"/>
+            <a:r>
+              <a:rPr lang="en-GB" dirty="0"/>
+              <a:t>as you’ll see using  </a:t>
+            </a:r>
+            <a:r>
+              <a:rPr lang="en-GB" dirty="0" err="1"/>
+              <a:t>BlynkLib</a:t>
+            </a:r>
+            <a:endParaRPr lang="en-IE" dirty="0"/>
+          </a:p>
+          <a:p>
+            <a:pPr lvl="1"/>
+            <a:endParaRPr lang="en-IE" dirty="0"/>
+          </a:p>
+        </p:txBody>
+      </p:sp>
+      <p:pic>
+        <p:nvPicPr>
+          <p:cNvPr id="5" name="Picture 4">
+            <a:extLst>
+              <a:ext uri="{FF2B5EF4-FFF2-40B4-BE49-F238E27FC236}">
+                <a16:creationId xmlns:a16="http://schemas.microsoft.com/office/drawing/2014/main" id="{9621D28E-D9EE-62AB-2BA5-BB32B3056AC4}"/>
+              </a:ext>
+            </a:extLst>
+          </p:cNvPr>
+          <p:cNvPicPr>
+            <a:picLocks noChangeAspect="1"/>
+          </p:cNvPicPr>
+          <p:nvPr/>
+        </p:nvPicPr>
+        <p:blipFill>
+          <a:blip r:embed="rId2"/>
+          <a:srcRect b="9665"/>
+          <a:stretch>
+            <a:fillRect/>
+          </a:stretch>
+        </p:blipFill>
+        <p:spPr>
+          <a:xfrm>
+            <a:off x="7861050" y="759483"/>
+            <a:ext cx="5039657" cy="3561028"/>
+          </a:xfrm>
+          <a:prstGeom prst="rect">
+            <a:avLst/>
+          </a:prstGeom>
+          <a:ln>
+            <a:solidFill>
+              <a:schemeClr val="accent1"/>
+            </a:solidFill>
+          </a:ln>
+        </p:spPr>
+      </p:pic>
+      <p:sp>
+        <p:nvSpPr>
+          <p:cNvPr id="7" name="Arrow: Right 6">
+            <a:extLst>
+              <a:ext uri="{FF2B5EF4-FFF2-40B4-BE49-F238E27FC236}">
+                <a16:creationId xmlns:a16="http://schemas.microsoft.com/office/drawing/2014/main" id="{14927B61-F6D9-A052-A4CC-203785F38A1E}"/>
+              </a:ext>
+            </a:extLst>
+          </p:cNvPr>
+          <p:cNvSpPr/>
+          <p:nvPr/>
+        </p:nvSpPr>
+        <p:spPr>
+          <a:xfrm rot="21053707">
+            <a:off x="6381980" y="2658678"/>
+            <a:ext cx="1464178" cy="304800"/>
+          </a:xfrm>
+          <a:prstGeom prst="rightArrow">
+            <a:avLst/>
+          </a:prstGeom>
+        </p:spPr>
+        <p:style>
+          <a:lnRef idx="2">
+            <a:schemeClr val="accent1">
+              <a:shade val="15000"/>
+            </a:schemeClr>
+          </a:lnRef>
+          <a:fillRef idx="1">
+            <a:schemeClr val="accent1"/>
+          </a:fillRef>
+          <a:effectRef idx="0">
+            <a:schemeClr val="accent1"/>
+          </a:effectRef>
+          <a:fontRef idx="minor">
+            <a:schemeClr val="lt1"/>
+          </a:fontRef>
+        </p:style>
+        <p:txBody>
+          <a:bodyPr rtlCol="0" anchor="ctr"/>
+          <a:lstStyle/>
+          <a:p>
+            <a:pPr algn="ctr"/>
+            <a:endParaRPr lang="en-IE"/>
+          </a:p>
+        </p:txBody>
+      </p:sp>
+    </p:spTree>
+    <p:extLst>
+      <p:ext uri="{BB962C8B-B14F-4D97-AF65-F5344CB8AC3E}">
+        <p14:creationId xmlns:p14="http://schemas.microsoft.com/office/powerpoint/2010/main" val="1560515968"/>
+      </p:ext>
+    </p:extLst>
+  </p:cSld>
+  <p:clrMapOvr>
+    <a:masterClrMapping/>
+  </p:clrMapOvr>
+</p:sld>
+</file>
+
+<file path=ppt/slides/slide35.xml><?xml version="1.0" encoding="utf-8"?>
+<p:sld xmlns:a="http://schemas.openxmlformats.org/drawingml/2006/main" xmlns:r="http://schemas.openxmlformats.org/officeDocument/2006/relationships" xmlns:p="http://schemas.openxmlformats.org/presentationml/2006/main">
+  <p:cSld>
+    <p:spTree>
+      <p:nvGrpSpPr>
+        <p:cNvPr id="1" name=""/>
+        <p:cNvGrpSpPr/>
+        <p:nvPr/>
+      </p:nvGrpSpPr>
+      <p:grpSpPr>
+        <a:xfrm>
+          <a:off x="0" y="0"/>
+          <a:ext cx="0" cy="0"/>
+          <a:chOff x="0" y="0"/>
+          <a:chExt cx="0" cy="0"/>
+        </a:xfrm>
+      </p:grpSpPr>
+      <p:sp>
+        <p:nvSpPr>
+          <p:cNvPr id="2" name="Title 1">
+            <a:extLst>
+              <a:ext uri="{FF2B5EF4-FFF2-40B4-BE49-F238E27FC236}">
+                <a16:creationId xmlns:a16="http://schemas.microsoft.com/office/drawing/2014/main" id="{23F52E99-A066-7C56-CE31-797F05BCE20B}"/>
+              </a:ext>
+            </a:extLst>
+          </p:cNvPr>
+          <p:cNvSpPr>
+            <a:spLocks noGrp="1"/>
+          </p:cNvSpPr>
+          <p:nvPr>
+            <p:ph type="title"/>
+          </p:nvPr>
+        </p:nvSpPr>
+        <p:spPr/>
+        <p:txBody>
+          <a:bodyPr/>
+          <a:lstStyle/>
+          <a:p>
+            <a:r>
+              <a:rPr lang="en-GB" dirty="0"/>
+              <a:t>Python Features: </a:t>
+            </a:r>
+            <a:r>
+              <a:rPr lang="en-GB" b="1" dirty="0"/>
+              <a:t>Datetime</a:t>
+            </a:r>
+            <a:r>
+              <a:rPr lang="en-GB" dirty="0"/>
+              <a:t> module</a:t>
+            </a:r>
+            <a:endParaRPr lang="en-IE" dirty="0"/>
+          </a:p>
+        </p:txBody>
+      </p:sp>
+      <p:sp>
+        <p:nvSpPr>
+          <p:cNvPr id="3" name="Content Placeholder 2">
+            <a:extLst>
+              <a:ext uri="{FF2B5EF4-FFF2-40B4-BE49-F238E27FC236}">
+                <a16:creationId xmlns:a16="http://schemas.microsoft.com/office/drawing/2014/main" id="{16335F57-A47C-90CB-11C4-C5F09F3E4C3C}"/>
+              </a:ext>
+            </a:extLst>
+          </p:cNvPr>
+          <p:cNvSpPr>
+            <a:spLocks noGrp="1"/>
+          </p:cNvSpPr>
+          <p:nvPr>
+            <p:ph idx="1"/>
+          </p:nvPr>
+        </p:nvSpPr>
+        <p:spPr>
+          <a:xfrm>
+            <a:off x="838200" y="1825625"/>
+            <a:ext cx="6140570" cy="4351338"/>
+          </a:xfrm>
+        </p:spPr>
+        <p:txBody>
+          <a:bodyPr/>
+          <a:lstStyle/>
+          <a:p>
+            <a:r>
+              <a:rPr lang="en-GB" dirty="0"/>
+              <a:t>A built-in Python module for </a:t>
+            </a:r>
+            <a:r>
+              <a:rPr lang="en-GB" b="1" dirty="0"/>
+              <a:t>working with dates and times</a:t>
+            </a:r>
+          </a:p>
+          <a:p>
+            <a:r>
+              <a:rPr lang="en-GB" dirty="0"/>
+              <a:t>Parse, format, and display dates</a:t>
+            </a:r>
+          </a:p>
+          <a:p>
+            <a:r>
+              <a:rPr lang="en-GB" dirty="0"/>
+              <a:t>Do date arithmetic (e.g., </a:t>
+            </a:r>
+            <a:r>
+              <a:rPr lang="en-GB" i="1" dirty="0"/>
+              <a:t>5 days from now</a:t>
+            </a:r>
+            <a:r>
+              <a:rPr lang="en-GB" dirty="0"/>
+              <a:t>)</a:t>
+            </a:r>
+          </a:p>
+          <a:p>
+            <a:r>
+              <a:rPr lang="en-GB" dirty="0"/>
+              <a:t>Handle timestamps, scheduling, logging, time differences</a:t>
+            </a:r>
+            <a:endParaRPr lang="en-IE" dirty="0"/>
+          </a:p>
+        </p:txBody>
+      </p:sp>
+      <p:pic>
+        <p:nvPicPr>
+          <p:cNvPr id="5" name="Picture 4">
+            <a:extLst>
+              <a:ext uri="{FF2B5EF4-FFF2-40B4-BE49-F238E27FC236}">
+                <a16:creationId xmlns:a16="http://schemas.microsoft.com/office/drawing/2014/main" id="{EFE563F4-3973-FBCA-7897-CFB4DEFA2C91}"/>
+              </a:ext>
+            </a:extLst>
+          </p:cNvPr>
+          <p:cNvPicPr>
+            <a:picLocks noChangeAspect="1"/>
+          </p:cNvPicPr>
+          <p:nvPr/>
+        </p:nvPicPr>
+        <p:blipFill>
+          <a:blip r:embed="rId2"/>
+          <a:stretch>
+            <a:fillRect/>
+          </a:stretch>
+        </p:blipFill>
+        <p:spPr>
+          <a:xfrm>
+            <a:off x="7198765" y="1690688"/>
+            <a:ext cx="5584462" cy="3020526"/>
+          </a:xfrm>
+          <a:prstGeom prst="rect">
+            <a:avLst/>
+          </a:prstGeom>
+        </p:spPr>
+      </p:pic>
+    </p:spTree>
+    <p:extLst>
+      <p:ext uri="{BB962C8B-B14F-4D97-AF65-F5344CB8AC3E}">
+        <p14:creationId xmlns:p14="http://schemas.microsoft.com/office/powerpoint/2010/main" val="1003305070"/>
+      </p:ext>
+    </p:extLst>
+  </p:cSld>
+  <p:clrMapOvr>
+    <a:masterClrMapping/>
+  </p:clrMapOvr>
+</p:sld>
+</file>
+
+<file path=ppt/slides/slide36.xml><?xml version="1.0" encoding="utf-8"?>
+<p:sld xmlns:a="http://schemas.openxmlformats.org/drawingml/2006/main" xmlns:r="http://schemas.openxmlformats.org/officeDocument/2006/relationships" xmlns:p="http://schemas.openxmlformats.org/presentationml/2006/main">
+  <p:cSld>
+    <p:spTree>
+      <p:nvGrpSpPr>
+        <p:cNvPr id="1" name=""/>
+        <p:cNvGrpSpPr/>
+        <p:nvPr/>
+      </p:nvGrpSpPr>
+      <p:grpSpPr>
+        <a:xfrm>
+          <a:off x="0" y="0"/>
+          <a:ext cx="0" cy="0"/>
+          <a:chOff x="0" y="0"/>
+          <a:chExt cx="0" cy="0"/>
+        </a:xfrm>
+      </p:grpSpPr>
+      <p:sp>
+        <p:nvSpPr>
+          <p:cNvPr id="2" name="Title 1">
+            <a:extLst>
+              <a:ext uri="{FF2B5EF4-FFF2-40B4-BE49-F238E27FC236}">
+                <a16:creationId xmlns:a16="http://schemas.microsoft.com/office/drawing/2014/main" id="{6166AF94-7EC3-F2BD-00F8-CB78D505FA55}"/>
+              </a:ext>
+            </a:extLst>
+          </p:cNvPr>
+          <p:cNvSpPr>
+            <a:spLocks noGrp="1"/>
+          </p:cNvSpPr>
+          <p:nvPr>
+            <p:ph type="title"/>
+          </p:nvPr>
+        </p:nvSpPr>
+        <p:spPr/>
+        <p:txBody>
+          <a:bodyPr/>
+          <a:lstStyle/>
+          <a:p>
+            <a:r>
+              <a:rPr lang="en-GB" dirty="0"/>
+              <a:t>Python Features: </a:t>
+            </a:r>
+            <a:r>
+              <a:rPr lang="en-GB" b="1" dirty="0"/>
+              <a:t>Error Handling</a:t>
+            </a:r>
+            <a:endParaRPr lang="en-IE" dirty="0"/>
+          </a:p>
+        </p:txBody>
+      </p:sp>
+      <p:sp>
+        <p:nvSpPr>
+          <p:cNvPr id="3" name="Content Placeholder 2">
+            <a:extLst>
+              <a:ext uri="{FF2B5EF4-FFF2-40B4-BE49-F238E27FC236}">
+                <a16:creationId xmlns:a16="http://schemas.microsoft.com/office/drawing/2014/main" id="{90BD9908-15A8-4E66-A031-C600B887F1FB}"/>
+              </a:ext>
+            </a:extLst>
+          </p:cNvPr>
+          <p:cNvSpPr>
+            <a:spLocks noGrp="1"/>
+          </p:cNvSpPr>
+          <p:nvPr>
+            <p:ph idx="1"/>
+          </p:nvPr>
+        </p:nvSpPr>
+        <p:spPr/>
+        <p:txBody>
+          <a:bodyPr/>
+          <a:lstStyle/>
+          <a:p>
+            <a:r>
+              <a:rPr lang="en-GB" dirty="0"/>
+              <a:t>A way to elegantly </a:t>
+            </a:r>
+            <a:r>
+              <a:rPr lang="en-GB" b="1" dirty="0"/>
+              <a:t>catch and manage problems</a:t>
+            </a:r>
+            <a:r>
+              <a:rPr lang="en-GB" dirty="0"/>
+              <a:t> that happen while your program runs.</a:t>
+            </a:r>
+          </a:p>
+          <a:p>
+            <a:r>
+              <a:rPr lang="en-GB" dirty="0"/>
+              <a:t>Can be used to prevent your program from crashing.</a:t>
+            </a:r>
+          </a:p>
+          <a:p>
+            <a:r>
+              <a:rPr lang="en-GB" dirty="0"/>
+              <a:t>Uses </a:t>
+            </a:r>
+            <a:r>
+              <a:rPr lang="en-GB" sz="2400" dirty="0">
+                <a:highlight>
+                  <a:srgbClr val="C0C0C0"/>
+                </a:highlight>
+                <a:latin typeface="Courier New" panose="02070309020205020404" pitchFamily="49" charset="0"/>
+                <a:cs typeface="Courier New" panose="02070309020205020404" pitchFamily="49" charset="0"/>
+              </a:rPr>
+              <a:t>try</a:t>
+            </a:r>
+            <a:r>
+              <a:rPr lang="en-GB" dirty="0"/>
+              <a:t>, </a:t>
+            </a:r>
+            <a:r>
+              <a:rPr lang="en-GB" sz="2400" dirty="0">
+                <a:highlight>
+                  <a:srgbClr val="C0C0C0"/>
+                </a:highlight>
+                <a:latin typeface="Courier New" panose="02070309020205020404" pitchFamily="49" charset="0"/>
+                <a:cs typeface="Courier New" panose="02070309020205020404" pitchFamily="49" charset="0"/>
+              </a:rPr>
+              <a:t>except</a:t>
+            </a:r>
+            <a:r>
+              <a:rPr lang="en-GB" dirty="0"/>
+              <a:t>, </a:t>
+            </a:r>
+            <a:r>
+              <a:rPr lang="en-GB" sz="2400" dirty="0">
+                <a:highlight>
+                  <a:srgbClr val="C0C0C0"/>
+                </a:highlight>
+                <a:latin typeface="Courier New" panose="02070309020205020404" pitchFamily="49" charset="0"/>
+                <a:cs typeface="Courier New" panose="02070309020205020404" pitchFamily="49" charset="0"/>
+              </a:rPr>
+              <a:t>else</a:t>
+            </a:r>
+            <a:r>
+              <a:rPr lang="en-GB" dirty="0"/>
+              <a:t>, and </a:t>
+            </a:r>
+            <a:r>
+              <a:rPr lang="en-GB" sz="2400" dirty="0">
+                <a:highlight>
+                  <a:srgbClr val="C0C0C0"/>
+                </a:highlight>
+                <a:latin typeface="Courier New" panose="02070309020205020404" pitchFamily="49" charset="0"/>
+                <a:cs typeface="Courier New" panose="02070309020205020404" pitchFamily="49" charset="0"/>
+              </a:rPr>
+              <a:t>finally</a:t>
+            </a:r>
+            <a:r>
+              <a:rPr lang="en-GB" dirty="0"/>
+              <a:t> blocks.</a:t>
+            </a:r>
+          </a:p>
+          <a:p>
+            <a:r>
+              <a:rPr lang="en-GB" dirty="0"/>
+              <a:t>Use it to:</a:t>
+            </a:r>
+          </a:p>
+          <a:p>
+            <a:pPr lvl="1"/>
+            <a:r>
+              <a:rPr lang="en-GB" dirty="0"/>
+              <a:t>Handle expected issues (files missing, bad input, network errors)</a:t>
+            </a:r>
+          </a:p>
+          <a:p>
+            <a:pPr lvl="1"/>
+            <a:r>
+              <a:rPr lang="en-GB" dirty="0"/>
+              <a:t>Give clearer error messages</a:t>
+            </a:r>
+          </a:p>
+          <a:p>
+            <a:pPr lvl="1"/>
+            <a:r>
+              <a:rPr lang="en-GB" dirty="0"/>
+              <a:t>Keep your program running safely</a:t>
+            </a:r>
+          </a:p>
+          <a:p>
+            <a:pPr lvl="1"/>
+            <a:r>
+              <a:rPr lang="en-GB" dirty="0"/>
+              <a:t>Clean up resources (files, network connections)</a:t>
+            </a:r>
+            <a:endParaRPr lang="en-IE" dirty="0"/>
+          </a:p>
+        </p:txBody>
+      </p:sp>
+    </p:spTree>
+    <p:extLst>
+      <p:ext uri="{BB962C8B-B14F-4D97-AF65-F5344CB8AC3E}">
+        <p14:creationId xmlns:p14="http://schemas.microsoft.com/office/powerpoint/2010/main" val="1379242409"/>
+      </p:ext>
+    </p:extLst>
+  </p:cSld>
+  <p:clrMapOvr>
+    <a:masterClrMapping/>
+  </p:clrMapOvr>
+</p:sld>
+</file>
+
+<file path=ppt/slides/slide37.xml><?xml version="1.0" encoding="utf-8"?>
+<p:sld xmlns:a="http://schemas.openxmlformats.org/drawingml/2006/main" xmlns:r="http://schemas.openxmlformats.org/officeDocument/2006/relationships" xmlns:p="http://schemas.openxmlformats.org/presentationml/2006/main">
+  <p:cSld>
+    <p:spTree>
+      <p:nvGrpSpPr>
+        <p:cNvPr id="1" name=""/>
+        <p:cNvGrpSpPr/>
+        <p:nvPr/>
+      </p:nvGrpSpPr>
+      <p:grpSpPr>
+        <a:xfrm>
+          <a:off x="0" y="0"/>
+          <a:ext cx="0" cy="0"/>
+          <a:chOff x="0" y="0"/>
+          <a:chExt cx="0" cy="0"/>
+        </a:xfrm>
+      </p:grpSpPr>
+      <p:sp>
+        <p:nvSpPr>
+          <p:cNvPr id="2" name="Title 1">
+            <a:extLst>
+              <a:ext uri="{FF2B5EF4-FFF2-40B4-BE49-F238E27FC236}">
+                <a16:creationId xmlns:a16="http://schemas.microsoft.com/office/drawing/2014/main" id="{5D59FDA1-5753-DDD0-7351-8975DC843C9F}"/>
+              </a:ext>
+            </a:extLst>
+          </p:cNvPr>
+          <p:cNvSpPr>
+            <a:spLocks noGrp="1"/>
+          </p:cNvSpPr>
+          <p:nvPr>
+            <p:ph type="title"/>
+          </p:nvPr>
+        </p:nvSpPr>
+        <p:spPr/>
+        <p:txBody>
+          <a:bodyPr/>
+          <a:lstStyle/>
+          <a:p>
+            <a:r>
+              <a:rPr lang="en-GB" dirty="0"/>
+              <a:t>Python Features: Error Handling (and Dates!)</a:t>
+            </a:r>
+            <a:endParaRPr lang="en-IE" dirty="0"/>
+          </a:p>
+        </p:txBody>
+      </p:sp>
+      <p:pic>
+        <p:nvPicPr>
+          <p:cNvPr id="5" name="Picture 4">
+            <a:extLst>
+              <a:ext uri="{FF2B5EF4-FFF2-40B4-BE49-F238E27FC236}">
+                <a16:creationId xmlns:a16="http://schemas.microsoft.com/office/drawing/2014/main" id="{FAC2BCC4-B90C-3F4D-5A85-7F72074A6EC1}"/>
+              </a:ext>
+            </a:extLst>
+          </p:cNvPr>
+          <p:cNvPicPr>
+            <a:picLocks noChangeAspect="1"/>
+          </p:cNvPicPr>
+          <p:nvPr/>
+        </p:nvPicPr>
+        <p:blipFill>
+          <a:blip r:embed="rId2"/>
+          <a:stretch>
+            <a:fillRect/>
+          </a:stretch>
+        </p:blipFill>
+        <p:spPr>
+          <a:xfrm>
+            <a:off x="1084006" y="1422759"/>
+            <a:ext cx="7841341" cy="4765316"/>
+          </a:xfrm>
+          <a:prstGeom prst="rect">
+            <a:avLst/>
+          </a:prstGeom>
+        </p:spPr>
+      </p:pic>
+      <p:sp>
+        <p:nvSpPr>
+          <p:cNvPr id="6" name="Call-out: Line 5">
+            <a:extLst>
+              <a:ext uri="{FF2B5EF4-FFF2-40B4-BE49-F238E27FC236}">
+                <a16:creationId xmlns:a16="http://schemas.microsoft.com/office/drawing/2014/main" id="{6F60E280-BC08-B02E-78FB-8C41FF6BD9D8}"/>
+              </a:ext>
+            </a:extLst>
+          </p:cNvPr>
+          <p:cNvSpPr/>
+          <p:nvPr/>
+        </p:nvSpPr>
+        <p:spPr>
+          <a:xfrm>
+            <a:off x="9682373" y="1609572"/>
+            <a:ext cx="1533831" cy="1494503"/>
+          </a:xfrm>
+          <a:prstGeom prst="borderCallout1">
+            <a:avLst>
+              <a:gd name="adj1" fmla="val 18750"/>
+              <a:gd name="adj2" fmla="val -8333"/>
+              <a:gd name="adj3" fmla="val 77"/>
+              <a:gd name="adj4" fmla="val -533190"/>
+            </a:avLst>
+          </a:prstGeom>
+        </p:spPr>
+        <p:style>
+          <a:lnRef idx="2">
+            <a:schemeClr val="accent1">
+              <a:shade val="15000"/>
+            </a:schemeClr>
+          </a:lnRef>
+          <a:fillRef idx="1">
+            <a:schemeClr val="accent1"/>
+          </a:fillRef>
+          <a:effectRef idx="0">
+            <a:schemeClr val="accent1"/>
+          </a:effectRef>
+          <a:fontRef idx="minor">
+            <a:schemeClr val="lt1"/>
+          </a:fontRef>
+        </p:style>
+        <p:txBody>
+          <a:bodyPr rtlCol="0" anchor="ctr"/>
+          <a:lstStyle/>
+          <a:p>
+            <a:pPr algn="ctr"/>
+            <a:r>
+              <a:rPr lang="en-GB" b="1" dirty="0"/>
+              <a:t>Try </a:t>
+            </a:r>
+            <a:r>
+              <a:rPr lang="en-GB" dirty="0"/>
+              <a:t>to run this code, but be ready to catch errors</a:t>
+            </a:r>
+            <a:endParaRPr lang="en-IE" dirty="0"/>
+          </a:p>
+        </p:txBody>
+      </p:sp>
+      <p:sp>
+        <p:nvSpPr>
+          <p:cNvPr id="7" name="Call-out: Line 6">
+            <a:extLst>
+              <a:ext uri="{FF2B5EF4-FFF2-40B4-BE49-F238E27FC236}">
+                <a16:creationId xmlns:a16="http://schemas.microsoft.com/office/drawing/2014/main" id="{7736B22B-34C5-0704-38E5-B5DCCE0E56E3}"/>
+              </a:ext>
+            </a:extLst>
+          </p:cNvPr>
+          <p:cNvSpPr/>
+          <p:nvPr/>
+        </p:nvSpPr>
+        <p:spPr>
+          <a:xfrm>
+            <a:off x="9682373" y="3244850"/>
+            <a:ext cx="1939356" cy="2723331"/>
+          </a:xfrm>
+          <a:prstGeom prst="borderCallout1">
+            <a:avLst>
+              <a:gd name="adj1" fmla="val 18750"/>
+              <a:gd name="adj2" fmla="val -8333"/>
+              <a:gd name="adj3" fmla="val 59268"/>
+              <a:gd name="adj4" fmla="val -303324"/>
+            </a:avLst>
+          </a:prstGeom>
+        </p:spPr>
+        <p:style>
+          <a:lnRef idx="2">
+            <a:schemeClr val="accent1">
+              <a:shade val="15000"/>
+            </a:schemeClr>
+          </a:lnRef>
+          <a:fillRef idx="1">
+            <a:schemeClr val="accent1"/>
+          </a:fillRef>
+          <a:effectRef idx="0">
+            <a:schemeClr val="accent1"/>
+          </a:effectRef>
+          <a:fontRef idx="minor">
+            <a:schemeClr val="lt1"/>
+          </a:fontRef>
+        </p:style>
+        <p:txBody>
+          <a:bodyPr rtlCol="0" anchor="ctr"/>
+          <a:lstStyle/>
+          <a:p>
+            <a:pPr algn="ctr"/>
+            <a:r>
+              <a:rPr lang="en-GB" dirty="0"/>
+              <a:t>If an exception (error) of the type you specify happens (here: </a:t>
+            </a:r>
+            <a:r>
+              <a:rPr lang="en-GB" dirty="0" err="1"/>
+              <a:t>ValueError</a:t>
+            </a:r>
+            <a:r>
+              <a:rPr lang="en-GB" dirty="0"/>
+              <a:t>),</a:t>
+            </a:r>
+            <a:br>
+              <a:rPr lang="en-GB" dirty="0"/>
+            </a:br>
+            <a:r>
+              <a:rPr lang="en-GB" dirty="0"/>
+              <a:t>it </a:t>
+            </a:r>
+            <a:r>
+              <a:rPr lang="en-GB" b="1" dirty="0"/>
+              <a:t>jumps out of the try block</a:t>
+            </a:r>
+            <a:r>
+              <a:rPr lang="en-GB" dirty="0"/>
+              <a:t> and into the matching except block.</a:t>
+            </a:r>
+            <a:endParaRPr lang="en-IE" dirty="0"/>
+          </a:p>
+        </p:txBody>
+      </p:sp>
+    </p:spTree>
+    <p:extLst>
+      <p:ext uri="{BB962C8B-B14F-4D97-AF65-F5344CB8AC3E}">
+        <p14:creationId xmlns:p14="http://schemas.microsoft.com/office/powerpoint/2010/main" val="576270156"/>
+      </p:ext>
+    </p:extLst>
+  </p:cSld>
+  <p:clrMapOvr>
+    <a:masterClrMapping/>
+  </p:clrMapOvr>
+</p:sld>
+</file>
+
+<file path=ppt/slides/slide38.xml><?xml version="1.0" encoding="utf-8"?>
+<p:sld xmlns:a="http://schemas.openxmlformats.org/drawingml/2006/main" xmlns:r="http://schemas.openxmlformats.org/officeDocument/2006/relationships" xmlns:p="http://schemas.openxmlformats.org/presentationml/2006/main">
+  <p:cSld>
+    <p:spTree>
+      <p:nvGrpSpPr>
+        <p:cNvPr id="1" name=""/>
+        <p:cNvGrpSpPr/>
+        <p:nvPr/>
+      </p:nvGrpSpPr>
+      <p:grpSpPr>
+        <a:xfrm>
+          <a:off x="0" y="0"/>
+          <a:ext cx="0" cy="0"/>
+          <a:chOff x="0" y="0"/>
+          <a:chExt cx="0" cy="0"/>
+        </a:xfrm>
+      </p:grpSpPr>
+      <p:sp>
+        <p:nvSpPr>
+          <p:cNvPr id="2" name="Title 1">
+            <a:extLst>
+              <a:ext uri="{FF2B5EF4-FFF2-40B4-BE49-F238E27FC236}">
                 <a16:creationId xmlns:a16="http://schemas.microsoft.com/office/drawing/2014/main" id="{F3C6E687-DC6F-03CA-15DC-96A1A5A1CBAD}"/>
               </a:ext>
             </a:extLst>

</xml_diff>